<commit_message>
proposal v0.32: shift benchmark to downstream decision utility
</commit_message>
<xml_diff>
--- a/deliverables/DeepAlign-Bench_一页汇报图.pptx
+++ b/deliverables/DeepAlign-Bench_一页汇报图.pptx
@@ -2,13 +2,13 @@
 <file path=ppt/presentation.xml><?xml version="1.0" encoding="utf-8"?>
 <p:presentation xmlns:p="http://schemas.openxmlformats.org/presentationml/2006/main">
   <p:sldMasterIdLst>
-    <p:sldMasterId xmlns:r="http://schemas.openxmlformats.org/officeDocument/2006/relationships" id="2147483648" r:id="R97e46704147a4cd5"/>
+    <p:sldMasterId xmlns:r="http://schemas.openxmlformats.org/officeDocument/2006/relationships" id="2147483648" r:id="R516b9e751ede44ee"/>
   </p:sldMasterIdLst>
   <p:notesMasterIdLst>
-    <p:notesMasterId xmlns:r="http://schemas.openxmlformats.org/officeDocument/2006/relationships" r:id="R4b95c24a10fc481f"/>
+    <p:notesMasterId xmlns:r="http://schemas.openxmlformats.org/officeDocument/2006/relationships" r:id="Ra84720b350a048f8"/>
   </p:notesMasterIdLst>
   <p:sldIdLst>
-    <p:sldId xmlns:r="http://schemas.openxmlformats.org/officeDocument/2006/relationships" id="256" r:id="Re207ce85ead9483e"/>
+    <p:sldId xmlns:r="http://schemas.openxmlformats.org/officeDocument/2006/relationships" id="256" r:id="R95bba36847b0410b"/>
   </p:sldIdLst>
   <p:sldSz cx="18288000" cy="10287000"/>
   <p:notesSz cx="6858000" cy="9144000"/>
@@ -470,6 +470,31 @@
               <a:t>Preference-Aware Rubric Learning for Personalized Evaluation — https://arxiv.org/abs/2605.31545</a:t>
             </a:r>
           </a:p>
+          <a:p xmlns:a="http://schemas.openxmlformats.org/drawingml/2006/main">
+            <a:r>
+              <a:t>v0.32 讲法：Phase A 只确认报告处理成立；Phase B 把报告作为处理，主测真实用户 decision regret。若 CFA 高而 DDE≈0，说明 artifact-fit 不是充分代理。</a:t>
+            </a:r>
+          </a:p>
+          <a:p xmlns:a="http://schemas.openxmlformats.org/drawingml/2006/main">
+            <a:r>
+              <a:t>[Sources]</a:t>
+            </a:r>
+          </a:p>
+          <a:p xmlns:a="http://schemas.openxmlformats.org/drawingml/2006/main">
+            <a:r>
+              <a:t>Project figure — proposal_assets/DeepAlign-Bench_主图.png</a:t>
+            </a:r>
+          </a:p>
+          <a:p xmlns:a="http://schemas.openxmlformats.org/drawingml/2006/main">
+            <a:r>
+              <a:t>Literature map — proposal/DeepAlign-Bench_相关论文全景与方向收敛.md</a:t>
+            </a:r>
+          </a:p>
+          <a:p xmlns:a="http://schemas.openxmlformats.org/drawingml/2006/main">
+            <a:r>
+              <a:t>Formal methods — proposal/DeepAlign-Bench_研究Proposal.md</a:t>
+            </a:r>
+          </a:p>
         </p:txBody>
       </p:sp>
       <p:sp>
@@ -535,7 +560,7 @@
   </p:cSld>
   <p:clrMap bg1="lt1" tx1="dk1" bg2="lt2" tx2="dk2" accent1="accent1" accent2="accent2" accent3="accent3" accent4="accent4" accent5="accent5" accent6="accent6" hlink="hlink" folHlink="folHlink"/>
   <p:sldLayoutIdLst>
-    <p:sldLayoutId xmlns:r="http://schemas.openxmlformats.org/officeDocument/2006/relationships" id="2147483649" r:id="R4c163aea6a094ddc"/>
+    <p:sldLayoutId xmlns:r="http://schemas.openxmlformats.org/officeDocument/2006/relationships" id="2147483649" r:id="Rfe48124fec584e0f"/>
   </p:sldLayoutIdLst>
   <p:txStyles>
     <p:titleStyle>
@@ -1090,11 +1115,11 @@
           <p:nvPr/>
         </p:nvPicPr>
         <p:blipFill>
-          <a:blip xmlns:r="http://schemas.openxmlformats.org/officeDocument/2006/relationships" xmlns:a="http://schemas.openxmlformats.org/drawingml/2006/main" r:embed="Rccb931feedaa4598"/>
+          <a:blip xmlns:r="http://schemas.openxmlformats.org/officeDocument/2006/relationships" xmlns:a="http://schemas.openxmlformats.org/drawingml/2006/main" r:embed="Rb6509956d4824fc9"/>
           <a:stretch xmlns:a="http://schemas.openxmlformats.org/drawingml/2006/main"/>
         </p:blipFill>
         <p:spPr>
-          <a:xfrm xmlns:a="http://schemas.openxmlformats.org/drawingml/2006/main">
+          <a:xfrm xmlns:a="http://schemas.openxmlformats.org/drawingml/2006/main" flipH="0" flipV="0">
             <a:off x="0" y="0"/>
             <a:ext cx="18288000" cy="10287000"/>
           </a:xfrm>

</xml_diff>